<commit_message>
Update Follow-up 2 with the corrected PPAP dates, PV counts and time split
DOC and DPF go to PPAP in November with production in January, and SCR's
PPAP is in January. Results now show 25 PV parts corrected (18 DOC, 3 long
and 4 short canning) and 7 SCR endout parts, with sideout on hold for
metrology. Slide 9 adds the month's time split, 70% industrialization and
30% cells.

Co-Authored-By: Claude Opus 5.5 <noreply@anthropic.com>
Claude-Session: https://claude.ai/code/session_012Ye9scek5k3HGgfD9p6dky
</commit_message>
<xml_diff>
--- a/presentations/Tenneco_FollowUp2_RoboticWelding_Diego_de_Leon.pptx
+++ b/presentations/Tenneco_FollowUp2_RoboticWelding_Diego_de_Leon.pptx
@@ -819,17 +819,27 @@
           <a:lstStyle/>
           <a:p>
             <a:r>
-              <a:t>• Problem: parallelism on DPF parts that were already released.</a:t>
-            </a:r>
-          </a:p>
-          <a:p>
-            <a:r>
-              <a:t>• Action: full re-measurement with a metrology expert, 8 DPF remade.</a:t>
-            </a:r>
-          </a:p>
-          <a:p>
-            <a:r>
-              <a:t>• Status: DOC and DPF 95%, only documents; SCR started, 14 PVs released.</a:t>
+              <a:t>• Problem: parallelism on parts that were already released.</a:t>
+            </a:r>
+          </a:p>
+          <a:p>
+            <a:r>
+              <a:t>• Action: full re-measurement with a metrology expert, 25 PVs corrected.</a:t>
+            </a:r>
+          </a:p>
+          <a:p>
+            <a:r>
+              <a:t>• DOC and DPF: PPAP in November, production in January.</a:t>
+            </a:r>
+          </a:p>
+          <a:p>
+            <a:r>
+              <a:t>• SCR: endout 7 parts; sideout stopped, no measurement assured yet.</a:t>
+            </a:r>
+          </a:p>
+          <a:p>
+            <a:r>
+              <a:t>• My time: 70% industrialization, 30% cells (it was 60/40).</a:t>
             </a:r>
           </a:p>
         </p:txBody>
@@ -909,7 +919,12 @@
           </a:p>
           <a:p>
             <a:r>
-              <a:t>• 8 DPF remade after the metrology check; 14 SCR PVs already released.</a:t>
+              <a:t>• 25 PVs corrected after the metrology check.</a:t>
+            </a:r>
+          </a:p>
+          <a:p>
+            <a:r>
+              <a:t>• SCR: 7 endout parts built; sideout stopped by metrology.</a:t>
             </a:r>
           </a:p>
         </p:txBody>
@@ -1539,7 +1554,12 @@
           </a:p>
           <a:p>
             <a:r>
-              <a:t>• DOC and DPF at 95%, PPAP in the first week of January.</a:t>
+              <a:t>• DOC and DPF at 95%: PPAP in November, production in January.</a:t>
+            </a:r>
+          </a:p>
+          <a:p>
+            <a:r>
+              <a:t>• SCR: PPAP in January; sideout is on hold for metrology.</a:t>
             </a:r>
           </a:p>
         </p:txBody>
@@ -15755,7 +15775,7 @@
                 </a:solidFill>
                 <a:latin typeface="Segoe UI"/>
               </a:rPr>
-              <a:t>Industrialization: DOC and DPF at 95%, SCR started</a:t>
+              <a:t>Industrialization: DOC and DPF go to PPAP in November</a:t>
             </a:r>
           </a:p>
         </p:txBody>
@@ -15904,7 +15924,7 @@
                 </a:solidFill>
                 <a:latin typeface="Segoe UI"/>
               </a:rPr>
-              <a:t>DPF parts already released failed metrology: parallelism out of tolerance.</a:t>
+              <a:t>DOC and DPF parts already released failed metrology. The main failure: parallelism.</a:t>
             </a:r>
           </a:p>
         </p:txBody>
@@ -15991,7 +16011,7 @@
                 </a:solidFill>
                 <a:latin typeface="Segoe UI"/>
               </a:rPr>
-              <a:t>A metrology expert measured everything again, and we remade 8 DPF parts: 4 short and 4 long canning.</a:t>
+              <a:t>A metrology expert measured everything again, and we corrected 25 PV parts: 18 DOC, 3 long and 4 short canning.</a:t>
             </a:r>
           </a:p>
         </p:txBody>
@@ -16078,7 +16098,7 @@
                 </a:solidFill>
                 <a:latin typeface="Segoe UI"/>
               </a:rPr>
-              <a:t>DOC and DPF at 95%, only documentation left. SCR started in October: 7 PV parts of each of two models, released.</a:t>
+              <a:t>DOC and DPF at 95%: PPAP in November, production in January. SCR: 7 endout parts built, sideout on hold, PPAP in January.</a:t>
             </a:r>
           </a:p>
         </p:txBody>
@@ -16205,7 +16225,7 @@
                 </a:solidFill>
                 <a:latin typeface="Segoe UI"/>
               </a:rPr>
-              <a:t>DPF parts or the metrology check</a:t>
+              <a:t>DOC and DPF parts, or the metrology check</a:t>
             </a:r>
           </a:p>
         </p:txBody>
@@ -16247,45 +16267,14 @@
       </p:sp>
       <p:sp>
         <p:nvSpPr>
-          <p:cNvPr id="15" name="Rectangle 14"/>
-          <p:cNvSpPr/>
-          <p:nvPr/>
-        </p:nvSpPr>
-        <p:spPr>
-          <a:xfrm>
-            <a:off x="6519672" y="3776472"/>
-            <a:ext cx="5276088" cy="1572768"/>
-          </a:xfrm>
-          <a:prstGeom prst="rect">
-            <a:avLst/>
-          </a:prstGeom>
-          <a:noFill/>
-          <a:ln w="9525">
-            <a:solidFill>
-              <a:srgbClr val="6B7A83">
-                <a:alpha val="35000"/>
-              </a:srgbClr>
-            </a:solidFill>
-          </a:ln>
-        </p:spPr>
-        <p:txBody>
-          <a:bodyPr rtlCol="0" anchor="ctr" wrap="square" lIns="0" rIns="0" tIns="0" bIns="0"/>
-          <a:lstStyle/>
-          <a:p>
-            <a:pPr algn="ctr"/>
-          </a:p>
-        </p:txBody>
-      </p:sp>
-      <p:sp>
-        <p:nvSpPr>
-          <p:cNvPr id="16" name="TextBox 15"/>
+          <p:cNvPr id="15" name="TextBox 14"/>
           <p:cNvSpPr txBox="1"/>
           <p:nvPr/>
         </p:nvSpPr>
         <p:spPr>
           <a:xfrm>
-            <a:off x="6382512" y="4306824"/>
-            <a:ext cx="5550408" cy="548640"/>
+            <a:off x="6720840" y="3822191"/>
+            <a:ext cx="4937760" cy="274320"/>
           </a:xfrm>
           <a:prstGeom prst="rect">
             <a:avLst/>
@@ -16298,7 +16287,7 @@
           </a:bodyPr>
           <a:lstStyle/>
           <a:p>
-            <a:pPr algn="ctr">
+            <a:pPr algn="l">
               <a:spcBef>
                 <a:spcPts val="0"/>
               </a:spcBef>
@@ -16307,32 +16296,199 @@
               </a:spcAft>
             </a:pPr>
             <a:r>
-              <a:rPr sz="1100" b="1">
+              <a:rPr sz="1600" b="1">
                 <a:solidFill>
                   <a:srgbClr val="0033A0"/>
                 </a:solidFill>
                 <a:latin typeface="Segoe UI"/>
               </a:rPr>
-              <a:t>PHOTO</a:t>
-            </a:r>
-          </a:p>
-          <a:p>
-            <a:pPr algn="ctr">
+              <a:t>MY TIME THIS MONTH</a:t>
+            </a:r>
+          </a:p>
+        </p:txBody>
+      </p:sp>
+      <p:sp>
+        <p:nvSpPr>
+          <p:cNvPr id="16" name="TextBox 15"/>
+          <p:cNvSpPr txBox="1"/>
+          <p:nvPr/>
+        </p:nvSpPr>
+        <p:spPr>
+          <a:xfrm>
+            <a:off x="6720840" y="4206240"/>
+            <a:ext cx="1371600" cy="548640"/>
+          </a:xfrm>
+          <a:prstGeom prst="rect">
+            <a:avLst/>
+          </a:prstGeom>
+          <a:noFill/>
+        </p:spPr>
+        <p:txBody>
+          <a:bodyPr wrap="square" lIns="0" rIns="0" tIns="0" bIns="0" anchor="t">
+            <a:spAutoFit/>
+          </a:bodyPr>
+          <a:lstStyle/>
+          <a:p>
+            <a:pPr algn="l">
               <a:spcBef>
-                <a:spcPts val="200"/>
+                <a:spcPts val="0"/>
               </a:spcBef>
               <a:spcAft>
                 <a:spcPts val="0"/>
               </a:spcAft>
             </a:pPr>
             <a:r>
-              <a:rPr sz="1200" b="0">
-                <a:solidFill>
-                  <a:srgbClr val="6B7A83"/>
+              <a:rPr sz="3000" b="1">
+                <a:solidFill>
+                  <a:srgbClr val="0033A0"/>
                 </a:solidFill>
                 <a:latin typeface="Segoe UI"/>
               </a:rPr>
-              <a:t>The SCR model</a:t>
+              <a:t>70%</a:t>
+            </a:r>
+          </a:p>
+        </p:txBody>
+      </p:sp>
+      <p:sp>
+        <p:nvSpPr>
+          <p:cNvPr id="17" name="TextBox 16"/>
+          <p:cNvSpPr txBox="1"/>
+          <p:nvPr/>
+        </p:nvSpPr>
+        <p:spPr>
+          <a:xfrm>
+            <a:off x="8092440" y="4297680"/>
+            <a:ext cx="3566160" cy="411480"/>
+          </a:xfrm>
+          <a:prstGeom prst="rect">
+            <a:avLst/>
+          </a:prstGeom>
+          <a:noFill/>
+        </p:spPr>
+        <p:txBody>
+          <a:bodyPr wrap="square" lIns="0" rIns="0" tIns="0" bIns="0" anchor="t">
+            <a:spAutoFit/>
+          </a:bodyPr>
+          <a:lstStyle/>
+          <a:p>
+            <a:pPr algn="l">
+              <a:spcBef>
+                <a:spcPts val="0"/>
+              </a:spcBef>
+              <a:spcAft>
+                <a:spcPts val="0"/>
+              </a:spcAft>
+            </a:pPr>
+            <a:r>
+              <a:rPr sz="1300" b="1">
+                <a:solidFill>
+                  <a:srgbClr val="051C2C"/>
+                </a:solidFill>
+                <a:latin typeface="Segoe UI"/>
+              </a:rPr>
+              <a:t>industrialization, with Engineering</a:t>
+            </a:r>
+          </a:p>
+        </p:txBody>
+      </p:sp>
+      <p:sp>
+        <p:nvSpPr>
+          <p:cNvPr id="18" name="Rectangle 17"/>
+          <p:cNvSpPr/>
+          <p:nvPr/>
+        </p:nvSpPr>
+        <p:spPr>
+          <a:xfrm>
+            <a:off x="6720840" y="4846320"/>
+            <a:ext cx="4892040" cy="128016"/>
+          </a:xfrm>
+          <a:prstGeom prst="rect">
+            <a:avLst/>
+          </a:prstGeom>
+          <a:solidFill>
+            <a:srgbClr val="051C2C">
+              <a:alpha val="15000"/>
+            </a:srgbClr>
+          </a:solidFill>
+          <a:ln>
+            <a:noFill/>
+          </a:ln>
+        </p:spPr>
+        <p:txBody>
+          <a:bodyPr rtlCol="0" anchor="ctr" wrap="square" lIns="0" rIns="0" tIns="0" bIns="0"/>
+          <a:lstStyle/>
+          <a:p>
+            <a:pPr algn="ctr"/>
+          </a:p>
+        </p:txBody>
+      </p:sp>
+      <p:sp>
+        <p:nvSpPr>
+          <p:cNvPr id="19" name="Rectangle 18"/>
+          <p:cNvSpPr/>
+          <p:nvPr/>
+        </p:nvSpPr>
+        <p:spPr>
+          <a:xfrm>
+            <a:off x="6720840" y="4846320"/>
+            <a:ext cx="3424427" cy="128016"/>
+          </a:xfrm>
+          <a:prstGeom prst="rect">
+            <a:avLst/>
+          </a:prstGeom>
+          <a:solidFill>
+            <a:srgbClr val="0033A0"/>
+          </a:solidFill>
+          <a:ln>
+            <a:noFill/>
+          </a:ln>
+        </p:spPr>
+        <p:txBody>
+          <a:bodyPr rtlCol="0" anchor="ctr" wrap="square" lIns="0" rIns="0" tIns="0" bIns="0"/>
+          <a:lstStyle/>
+          <a:p>
+            <a:pPr algn="ctr"/>
+          </a:p>
+        </p:txBody>
+      </p:sp>
+      <p:sp>
+        <p:nvSpPr>
+          <p:cNvPr id="20" name="TextBox 19"/>
+          <p:cNvSpPr txBox="1"/>
+          <p:nvPr/>
+        </p:nvSpPr>
+        <p:spPr>
+          <a:xfrm>
+            <a:off x="6720840" y="5074920"/>
+            <a:ext cx="4937760" cy="274320"/>
+          </a:xfrm>
+          <a:prstGeom prst="rect">
+            <a:avLst/>
+          </a:prstGeom>
+          <a:noFill/>
+        </p:spPr>
+        <p:txBody>
+          <a:bodyPr wrap="square" lIns="0" rIns="0" tIns="0" bIns="0" anchor="t">
+            <a:spAutoFit/>
+          </a:bodyPr>
+          <a:lstStyle/>
+          <a:p>
+            <a:pPr algn="l">
+              <a:spcBef>
+                <a:spcPts val="0"/>
+              </a:spcBef>
+              <a:spcAft>
+                <a:spcPts val="0"/>
+              </a:spcAft>
+            </a:pPr>
+            <a:r>
+              <a:rPr sz="1200" b="0">
+                <a:solidFill>
+                  <a:srgbClr val="6B7A83"/>
+                </a:solidFill>
+                <a:latin typeface="Segoe UI"/>
+              </a:rPr>
+              <a:t>30%  support at the robotic cells</a:t>
             </a:r>
           </a:p>
         </p:txBody>
@@ -16816,7 +16972,7 @@
                 </a:solidFill>
                 <a:latin typeface="Segoe UI"/>
               </a:rPr>
-              <a:t>Only documentation left. PPAP in the first week of January.</a:t>
+              <a:t>Only documentation left. PPAP in November, production in January.</a:t>
             </a:r>
           </a:p>
         </p:txBody>
@@ -16984,7 +17140,7 @@
                 </a:solidFill>
                 <a:latin typeface="Segoe UI"/>
               </a:rPr>
-              <a:t>8</a:t>
+              <a:t>25</a:t>
             </a:r>
           </a:p>
         </p:txBody>
@@ -17026,7 +17182,7 @@
                 </a:solidFill>
                 <a:latin typeface="Segoe UI"/>
               </a:rPr>
-              <a:t>DPF parts remade</a:t>
+              <a:t>PV parts corrected</a:t>
             </a:r>
           </a:p>
         </p:txBody>
@@ -17068,7 +17224,7 @@
                 </a:solidFill>
                 <a:latin typeface="Segoe UI"/>
               </a:rPr>
-              <a:t>after re-measuring parallelism</a:t>
+              <a:t>18 DOC, 3 DPF long, 4 DPF short</a:t>
             </a:r>
           </a:p>
         </p:txBody>
@@ -17110,7 +17266,7 @@
                 </a:solidFill>
                 <a:latin typeface="Segoe UI"/>
               </a:rPr>
-              <a:t>14</a:t>
+              <a:t>7</a:t>
             </a:r>
           </a:p>
         </p:txBody>
@@ -17152,7 +17308,7 @@
                 </a:solidFill>
                 <a:latin typeface="Segoe UI"/>
               </a:rPr>
-              <a:t>SCR PV parts</a:t>
+              <a:t>SCR endout parts</a:t>
             </a:r>
           </a:p>
         </p:txBody>
@@ -17194,7 +17350,7 @@
                 </a:solidFill>
                 <a:latin typeface="Segoe UI"/>
               </a:rPr>
-              <a:t>two models, 7 each, released</a:t>
+              <a:t>sideout on hold for metrology</a:t>
             </a:r>
           </a:p>
         </p:txBody>
@@ -18020,7 +18176,7 @@
                 </a:solidFill>
                 <a:latin typeface="Segoe UI"/>
               </a:rPr>
-              <a:t>DOC and DPF PPAP</a:t>
+              <a:t>PPAP: DOC and DPF in November, SCR in January</a:t>
             </a:r>
           </a:p>
         </p:txBody>
@@ -18062,7 +18218,7 @@
                 </a:solidFill>
                 <a:latin typeface="Segoe UI"/>
               </a:rPr>
-              <a:t>First week of January</a:t>
+              <a:t>DOC and DPF production starts in January</a:t>
             </a:r>
           </a:p>
         </p:txBody>
@@ -18668,7 +18824,7 @@
                 </a:solidFill>
                 <a:latin typeface="Segoe UI"/>
               </a:rPr>
-              <a:t>DOC and DPF at 95%, and SCR started with 14 PV parts released.</a:t>
+              <a:t>DOC and DPF at 95%, with 25 PV parts corrected after metrology.</a:t>
             </a:r>
           </a:p>
         </p:txBody>
@@ -18836,7 +18992,7 @@
                 </a:solidFill>
                 <a:latin typeface="Segoe UI"/>
               </a:rPr>
-              <a:t>Support the DOC and DPF PPAP in the first week of January.</a:t>
+              <a:t>Support the DOC and DPF PPAP in November, and SCR’s in January.</a:t>
             </a:r>
           </a:p>
         </p:txBody>
@@ -24918,7 +25074,7 @@
                 </a:solidFill>
                 <a:latin typeface="Segoe UI"/>
               </a:rPr>
-              <a:t>PVs in 4M, PPAP in week 1</a:t>
+              <a:t>PPAP in November, production in January</a:t>
             </a:r>
           </a:p>
         </p:txBody>
@@ -24932,7 +25088,7 @@
         <p:spPr>
           <a:xfrm>
             <a:off x="7676586" y="4078224"/>
-            <a:ext cx="3699741" cy="201168"/>
+            <a:ext cx="4073453" cy="201168"/>
           </a:xfrm>
           <a:prstGeom prst="rect">
             <a:avLst/>
@@ -24989,7 +25145,7 @@
         </p:nvSpPr>
         <p:spPr>
           <a:xfrm>
-            <a:off x="11462600" y="4078224"/>
+            <a:off x="8099198" y="4078224"/>
             <a:ext cx="201168" cy="201168"/>
           </a:xfrm>
           <a:prstGeom prst="diamond">
@@ -25018,8 +25174,8 @@
         </p:nvSpPr>
         <p:spPr>
           <a:xfrm>
-            <a:off x="10603064" y="4078224"/>
-            <a:ext cx="777240" cy="201168"/>
+            <a:off x="8355230" y="4078224"/>
+            <a:ext cx="914400" cy="201168"/>
           </a:xfrm>
           <a:prstGeom prst="rect">
             <a:avLst/>
@@ -25032,7 +25188,7 @@
           </a:bodyPr>
           <a:lstStyle/>
           <a:p>
-            <a:pPr algn="r">
+            <a:pPr algn="l">
               <a:spcBef>
                 <a:spcPts val="0"/>
               </a:spcBef>
@@ -25054,7 +25210,78 @@
       </p:sp>
       <p:sp>
         <p:nvSpPr>
-          <p:cNvPr id="70" name="Rectangle 69"/>
+          <p:cNvPr id="70" name="Diamond 69"/>
+          <p:cNvSpPr/>
+          <p:nvPr/>
+        </p:nvSpPr>
+        <p:spPr>
+          <a:xfrm>
+            <a:off x="11462600" y="4078224"/>
+            <a:ext cx="201168" cy="201168"/>
+          </a:xfrm>
+          <a:prstGeom prst="diamond">
+            <a:avLst/>
+          </a:prstGeom>
+          <a:solidFill>
+            <a:srgbClr val="FFFFFF"/>
+          </a:solidFill>
+          <a:ln>
+            <a:noFill/>
+          </a:ln>
+        </p:spPr>
+        <p:txBody>
+          <a:bodyPr rtlCol="0" anchor="ctr" wrap="square" lIns="0" rIns="0" tIns="0" bIns="0"/>
+          <a:lstStyle/>
+          <a:p>
+            <a:pPr algn="ctr"/>
+          </a:p>
+        </p:txBody>
+      </p:sp>
+      <p:sp>
+        <p:nvSpPr>
+          <p:cNvPr id="71" name="TextBox 70"/>
+          <p:cNvSpPr txBox="1"/>
+          <p:nvPr/>
+        </p:nvSpPr>
+        <p:spPr>
+          <a:xfrm>
+            <a:off x="10420184" y="4078224"/>
+            <a:ext cx="960120" cy="201168"/>
+          </a:xfrm>
+          <a:prstGeom prst="rect">
+            <a:avLst/>
+          </a:prstGeom>
+          <a:noFill/>
+        </p:spPr>
+        <p:txBody>
+          <a:bodyPr wrap="square" lIns="0" rIns="0" tIns="0" bIns="0" anchor="t">
+            <a:spAutoFit/>
+          </a:bodyPr>
+          <a:lstStyle/>
+          <a:p>
+            <a:pPr algn="r">
+              <a:spcBef>
+                <a:spcPts val="0"/>
+              </a:spcBef>
+              <a:spcAft>
+                <a:spcPts val="0"/>
+              </a:spcAft>
+            </a:pPr>
+            <a:r>
+              <a:rPr sz="900" b="1">
+                <a:solidFill>
+                  <a:srgbClr val="051C2C"/>
+                </a:solidFill>
+                <a:latin typeface="Segoe UI"/>
+              </a:rPr>
+              <a:t>Production</a:t>
+            </a:r>
+          </a:p>
+        </p:txBody>
+      </p:sp>
+      <p:sp>
+        <p:nvSpPr>
+          <p:cNvPr id="72" name="Rectangle 71"/>
           <p:cNvSpPr/>
           <p:nvPr/>
         </p:nvSpPr>
@@ -25085,7 +25312,7 @@
       </p:sp>
       <p:sp>
         <p:nvSpPr>
-          <p:cNvPr id="71" name="TextBox 70"/>
+          <p:cNvPr id="73" name="TextBox 72"/>
           <p:cNvSpPr txBox="1"/>
           <p:nvPr/>
         </p:nvSpPr>
@@ -25127,7 +25354,7 @@
       </p:sp>
       <p:sp>
         <p:nvSpPr>
-          <p:cNvPr id="72" name="TextBox 71"/>
+          <p:cNvPr id="74" name="TextBox 73"/>
           <p:cNvSpPr txBox="1"/>
           <p:nvPr/>
         </p:nvSpPr>
@@ -25162,14 +25389,14 @@
                 </a:solidFill>
                 <a:latin typeface="Segoe UI"/>
               </a:rPr>
-              <a:t>DPF parallelism, 8 parts remade</a:t>
-            </a:r>
-          </a:p>
-        </p:txBody>
-      </p:sp>
-      <p:sp>
-        <p:nvSpPr>
-          <p:cNvPr id="73" name="Rectangle 72"/>
+              <a:t>PV corrections: 18 DOC, 7 DPF</a:t>
+            </a:r>
+          </a:p>
+        </p:txBody>
+      </p:sp>
+      <p:sp>
+        <p:nvSpPr>
+          <p:cNvPr id="75" name="Rectangle 74"/>
           <p:cNvSpPr/>
           <p:nvPr/>
         </p:nvSpPr>
@@ -25198,7 +25425,7 @@
       </p:sp>
       <p:sp>
         <p:nvSpPr>
-          <p:cNvPr id="74" name="Rectangle 73"/>
+          <p:cNvPr id="76" name="Rectangle 75"/>
           <p:cNvSpPr/>
           <p:nvPr/>
         </p:nvSpPr>
@@ -25229,7 +25456,7 @@
       </p:sp>
       <p:sp>
         <p:nvSpPr>
-          <p:cNvPr id="75" name="TextBox 74"/>
+          <p:cNvPr id="77" name="TextBox 76"/>
           <p:cNvSpPr txBox="1"/>
           <p:nvPr/>
         </p:nvSpPr>
@@ -25271,7 +25498,7 @@
       </p:sp>
       <p:sp>
         <p:nvSpPr>
-          <p:cNvPr id="76" name="TextBox 75"/>
+          <p:cNvPr id="78" name="TextBox 77"/>
           <p:cNvSpPr txBox="1"/>
           <p:nvPr/>
         </p:nvSpPr>
@@ -25306,14 +25533,14 @@
                 </a:solidFill>
                 <a:latin typeface="Segoe UI"/>
               </a:rPr>
-              <a:t>PVs of two models, released</a:t>
-            </a:r>
-          </a:p>
-        </p:txBody>
-      </p:sp>
-      <p:sp>
-        <p:nvSpPr>
-          <p:cNvPr id="77" name="Rectangle 76"/>
+              <a:t>Endout: 7 PVs. Sideout on hold</a:t>
+            </a:r>
+          </a:p>
+        </p:txBody>
+      </p:sp>
+      <p:sp>
+        <p:nvSpPr>
+          <p:cNvPr id="79" name="Rectangle 78"/>
           <p:cNvSpPr/>
           <p:nvPr/>
         </p:nvSpPr>
@@ -25342,7 +25569,7 @@
       </p:sp>
       <p:sp>
         <p:nvSpPr>
-          <p:cNvPr id="78" name="Rectangle 77"/>
+          <p:cNvPr id="80" name="Rectangle 79"/>
           <p:cNvSpPr/>
           <p:nvPr/>
         </p:nvSpPr>
@@ -25371,7 +25598,78 @@
       </p:sp>
       <p:sp>
         <p:nvSpPr>
-          <p:cNvPr id="79" name="Rectangle 78"/>
+          <p:cNvPr id="81" name="Diamond 80"/>
+          <p:cNvSpPr/>
+          <p:nvPr/>
+        </p:nvSpPr>
+        <p:spPr>
+          <a:xfrm>
+            <a:off x="11462600" y="4882896"/>
+            <a:ext cx="201168" cy="201168"/>
+          </a:xfrm>
+          <a:prstGeom prst="diamond">
+            <a:avLst/>
+          </a:prstGeom>
+          <a:solidFill>
+            <a:srgbClr val="FFFFFF"/>
+          </a:solidFill>
+          <a:ln>
+            <a:noFill/>
+          </a:ln>
+        </p:spPr>
+        <p:txBody>
+          <a:bodyPr rtlCol="0" anchor="ctr" wrap="square" lIns="0" rIns="0" tIns="0" bIns="0"/>
+          <a:lstStyle/>
+          <a:p>
+            <a:pPr algn="ctr"/>
+          </a:p>
+        </p:txBody>
+      </p:sp>
+      <p:sp>
+        <p:nvSpPr>
+          <p:cNvPr id="82" name="TextBox 81"/>
+          <p:cNvSpPr txBox="1"/>
+          <p:nvPr/>
+        </p:nvSpPr>
+        <p:spPr>
+          <a:xfrm>
+            <a:off x="10420184" y="4882896"/>
+            <a:ext cx="960120" cy="201168"/>
+          </a:xfrm>
+          <a:prstGeom prst="rect">
+            <a:avLst/>
+          </a:prstGeom>
+          <a:noFill/>
+        </p:spPr>
+        <p:txBody>
+          <a:bodyPr wrap="square" lIns="0" rIns="0" tIns="0" bIns="0" anchor="t">
+            <a:spAutoFit/>
+          </a:bodyPr>
+          <a:lstStyle/>
+          <a:p>
+            <a:pPr algn="r">
+              <a:spcBef>
+                <a:spcPts val="0"/>
+              </a:spcBef>
+              <a:spcAft>
+                <a:spcPts val="0"/>
+              </a:spcAft>
+            </a:pPr>
+            <a:r>
+              <a:rPr sz="900" b="1">
+                <a:solidFill>
+                  <a:srgbClr val="051C2C"/>
+                </a:solidFill>
+                <a:latin typeface="Segoe UI"/>
+              </a:rPr>
+              <a:t>PPAP</a:t>
+            </a:r>
+          </a:p>
+        </p:txBody>
+      </p:sp>
+      <p:sp>
+        <p:nvSpPr>
+          <p:cNvPr id="83" name="Rectangle 82"/>
           <p:cNvSpPr/>
           <p:nvPr/>
         </p:nvSpPr>
@@ -25401,7 +25699,7 @@
       </p:sp>
       <p:sp>
         <p:nvSpPr>
-          <p:cNvPr id="80" name="TextBox 79"/>
+          <p:cNvPr id="84" name="TextBox 83"/>
           <p:cNvSpPr txBox="1"/>
           <p:nvPr/>
         </p:nvSpPr>
@@ -25443,7 +25741,7 @@
       </p:sp>
       <p:sp>
         <p:nvSpPr>
-          <p:cNvPr id="81" name="Rectangle 80"/>
+          <p:cNvPr id="85" name="Rectangle 84"/>
           <p:cNvSpPr/>
           <p:nvPr/>
         </p:nvSpPr>
@@ -25472,7 +25770,7 @@
       </p:sp>
       <p:sp>
         <p:nvSpPr>
-          <p:cNvPr id="82" name="TextBox 81"/>
+          <p:cNvPr id="86" name="TextBox 85"/>
           <p:cNvSpPr txBox="1"/>
           <p:nvPr/>
         </p:nvSpPr>
@@ -25514,7 +25812,7 @@
       </p:sp>
       <p:sp>
         <p:nvSpPr>
-          <p:cNvPr id="83" name="Rectangle 82"/>
+          <p:cNvPr id="87" name="Rectangle 86"/>
           <p:cNvSpPr/>
           <p:nvPr/>
         </p:nvSpPr>
@@ -25543,7 +25841,7 @@
       </p:sp>
       <p:sp>
         <p:nvSpPr>
-          <p:cNvPr id="84" name="TextBox 83"/>
+          <p:cNvPr id="88" name="TextBox 87"/>
           <p:cNvSpPr txBox="1"/>
           <p:nvPr/>
         </p:nvSpPr>
@@ -25585,7 +25883,7 @@
       </p:sp>
       <p:sp>
         <p:nvSpPr>
-          <p:cNvPr id="85" name="Diamond 84"/>
+          <p:cNvPr id="89" name="Diamond 88"/>
           <p:cNvSpPr/>
           <p:nvPr/>
         </p:nvSpPr>
@@ -25614,7 +25912,7 @@
       </p:sp>
       <p:sp>
         <p:nvSpPr>
-          <p:cNvPr id="86" name="TextBox 85"/>
+          <p:cNvPr id="90" name="TextBox 89"/>
           <p:cNvSpPr txBox="1"/>
           <p:nvPr/>
         </p:nvSpPr>
@@ -25656,7 +25954,7 @@
       </p:sp>
       <p:sp>
         <p:nvSpPr>
-          <p:cNvPr id="87" name="Diamond 86"/>
+          <p:cNvPr id="91" name="Diamond 90"/>
           <p:cNvSpPr/>
           <p:nvPr/>
         </p:nvSpPr>
@@ -25685,7 +25983,7 @@
       </p:sp>
       <p:sp>
         <p:nvSpPr>
-          <p:cNvPr id="88" name="TextBox 87"/>
+          <p:cNvPr id="92" name="TextBox 91"/>
           <p:cNvSpPr txBox="1"/>
           <p:nvPr/>
         </p:nvSpPr>
@@ -27897,7 +28195,7 @@
                 </a:solidFill>
                 <a:latin typeface="Segoe UI"/>
               </a:rPr>
-              <a:t>DPF parts that were already released started failing metrology. A metrology expert measured everything again: the main failure was parallelism.</a:t>
+              <a:t>DOC and DPF parts that were already released started failing metrology. A metrology expert measured everything again: the main failure was parallelism.</a:t>
             </a:r>
           </a:p>
           <a:p>
@@ -27919,7 +28217,7 @@
                 </a:solidFill>
                 <a:latin typeface="Segoe UI"/>
               </a:rPr>
-              <a:t>At the same time the SCR model started: bigger, heavier and harder to build, with more machines and processes.</a:t>
+              <a:t>At the same time the SCR model started: bigger, heavier and harder to build. One of its two models, sideout, is on hold for metrology too.</a:t>
             </a:r>
           </a:p>
         </p:txBody>

</xml_diff>